<commit_message>
docs: remove UNUD logo from closing slide of presentation
Co-Authored-By: Claude Opus 4.8 (1M context) <noreply@anthropic.com>
</commit_message>
<xml_diff>
--- a/doc/presentasi_audit_bwapp.pptx
+++ b/doc/presentasi_audit_bwapp.pptx
@@ -11766,30 +11766,6 @@
           </a:p>
         </p:txBody>
       </p:sp>
-      <p:pic>
-        <p:nvPicPr>
-          <p:cNvPr id="9" name="Picture 8" descr="unud_logo.png"/>
-          <p:cNvPicPr>
-            <a:picLocks noChangeAspect="1"/>
-          </p:cNvPicPr>
-          <p:nvPr/>
-        </p:nvPicPr>
-        <p:blipFill>
-          <a:blip r:embed="rId2"/>
-          <a:stretch>
-            <a:fillRect/>
-          </a:stretch>
-        </p:blipFill>
-        <p:spPr>
-          <a:xfrm>
-            <a:off x="9418320" y="3566160"/>
-            <a:ext cx="1829988" cy="2103120"/>
-          </a:xfrm>
-          <a:prstGeom prst="rect">
-            <a:avLst/>
-          </a:prstGeom>
-        </p:spPr>
-      </p:pic>
     </p:spTree>
   </p:cSld>
   <p:clrMapOvr>

</xml_diff>